<commit_message>
IDJ Rev2: BLK3-for-Japan adds potential U.S. asset reallocation (Jon 9/27)
Co-Authored-By: Claude Opus 5.5 <noreply@anthropic.com>
</commit_message>
<xml_diff>
--- a/drafts/Exos_Aerospace_Japan_Investor_Pitch_Rev2_2026-09-27.pptx
+++ b/drafts/Exos_Aerospace_Japan_Investor_Pitch_Rev2_2026-09-27.pptx
@@ -8420,13 +8420,13 @@
           <a:p>
             <a:pPr algn="l"/>
             <a:r>
-              <a:rPr sz="1250" b="0" i="0" dirty="0">
+              <a:rPr sz="1150" b="0" i="0" dirty="0">
                 <a:solidFill>
                   <a:srgbClr val="F5F5F5"/>
                 </a:solidFill>
                 <a:latin typeface="Aptos"/>
               </a:rPr>
-              <a:t>Seeking Japanese technical partners for licensed production of TRL-9 Type-5 tanks in Japan. BLK3-for-Japan production commences upon international approvals (incl. U.S. export).</a:t>
+              <a:t>Seeking Japanese technical partners for licensed production of TRL-9 Type-5 tanks in Japan. BLK3-for-Japan production commences upon international approvals (incl. U.S. export), with potential reallocation of U.S. BLK3 assets to match the speed of those approvals.</a:t>
             </a:r>
             <a:endParaRPr lang="en-US" sz="1250" b="0" i="0" dirty="0">
               <a:solidFill>

</xml_diff>

<commit_message>
IDJ decks: K.K.-only exit paths + not-an-offer disclaimer; v6 BLK3 reallocation line (Jon 9/27)
Co-Authored-By: Claude Opus 5.5 <noreply@anthropic.com>
</commit_message>
<xml_diff>
--- a/drafts/Exos_Aerospace_Japan_Investor_Pitch_Rev2_2026-09-27.pptx
+++ b/drafts/Exos_Aerospace_Japan_Investor_Pitch_Rev2_2026-09-27.pptx
@@ -6941,6 +6941,41 @@
           </a:p>
         </p:txBody>
       </p:sp>
+      <p:sp>
+        <p:nvSpPr>
+          <p:cNvPr id="4" name="Securities disclaimer"/>
+          <p:cNvSpPr txBox="1"/>
+          <p:nvPr/>
+        </p:nvSpPr>
+        <p:spPr>
+          <a:xfrm>
+            <a:off x="594360" y="6199632"/>
+            <a:ext cx="10515600" cy="228600"/>
+          </a:xfrm>
+          <a:prstGeom prst="rect">
+            <a:avLst/>
+          </a:prstGeom>
+          <a:noFill/>
+        </p:spPr>
+        <p:txBody>
+          <a:bodyPr wrap="none" lIns="18288" tIns="18288" rIns="18288" bIns="18288" anchor="t">
+            <a:spAutoFit/>
+          </a:bodyPr>
+          <a:lstStyle/>
+          <a:p>
+            <a:pPr algn="l"/>
+            <a:r>
+              <a:rPr sz="850" b="0" i="1">
+                <a:solidFill>
+                  <a:srgbClr val="B1B4B9"/>
+                </a:solidFill>
+                <a:latin typeface="Aptos"/>
+              </a:rPr>
+              <a:t>Not an offer of securities of Exos Aerospace Systems &amp; Technologies, Inc. Any offering by Exos Aerospace Japan K.K. will be made only through definitive documents to eligible investors.</a:t>
+            </a:r>
+          </a:p>
+        </p:txBody>
+      </p:sp>
     </p:spTree>
   </p:cSld>
   <p:clrMapOvr>
@@ -7529,7 +7564,7 @@
                 </a:solidFill>
                 <a:latin typeface="Aptos"/>
               </a:rPr>
-              <a:t>Roll into an Exos U.S. liquidity event: Series A close (raising now), public listing, or acquisition. Horizon ~3+ years.</a:t>
+              <a:t>Liquidity paths: acquisition of the K.K. stake by Exos U.S. or a strategic buyer, or a K.K.-level listing. Horizon ~3+ years.</a:t>
             </a:r>
           </a:p>
         </p:txBody>
@@ -7867,6 +7902,41 @@
                 <a:latin typeface="Aptos"/>
               </a:rPr>
               <a:t>06</a:t>
+            </a:r>
+          </a:p>
+        </p:txBody>
+      </p:sp>
+      <p:sp>
+        <p:nvSpPr>
+          <p:cNvPr id="4" name="Securities disclaimer"/>
+          <p:cNvSpPr txBox="1"/>
+          <p:nvPr/>
+        </p:nvSpPr>
+        <p:spPr>
+          <a:xfrm>
+            <a:off x="594360" y="6199632"/>
+            <a:ext cx="10515600" cy="228600"/>
+          </a:xfrm>
+          <a:prstGeom prst="rect">
+            <a:avLst/>
+          </a:prstGeom>
+          <a:noFill/>
+        </p:spPr>
+        <p:txBody>
+          <a:bodyPr wrap="square" anchor="t" lIns="0" rIns="0" tIns="0" bIns="0">
+            <a:spAutoFit/>
+          </a:bodyPr>
+          <a:lstStyle/>
+          <a:p>
+            <a:pPr algn="l"/>
+            <a:r>
+              <a:rPr sz="850" b="0" i="1">
+                <a:solidFill>
+                  <a:srgbClr val="B1B4B9"/>
+                </a:solidFill>
+                <a:latin typeface="Aptos"/>
+              </a:rPr>
+              <a:t>Not an offer of securities of Exos Aerospace Systems &amp; Technologies, Inc. Any offering by Exos Aerospace Japan K.K. will be made only through definitive documents to eligible investors.</a:t>
             </a:r>
           </a:p>
         </p:txBody>

</xml_diff>

<commit_message>
IDJ decks: investment via Exos U.S. offering vehicle; K.K. wholly-owned sub (Jon 9/27)
Co-Authored-By: Claude Opus 5.5 <noreply@anthropic.com>
</commit_message>
<xml_diff>
--- a/drafts/Exos_Aerospace_Japan_Investor_Pitch_Rev2_2026-09-27.pptx
+++ b/drafts/Exos_Aerospace_Japan_Investor_Pitch_Rev2_2026-09-27.pptx
@@ -5810,7 +5810,7 @@
                 </a:solidFill>
                 <a:latin typeface="Aptos"/>
               </a:rPr>
-              <a:t>A structured raise into the Japan entity</a:t>
+              <a:t>A structured raise to build Exos Aerospace Japan</a:t>
             </a:r>
           </a:p>
         </p:txBody>
@@ -5845,7 +5845,7 @@
                 </a:solidFill>
                 <a:latin typeface="Aptos"/>
               </a:rPr>
-              <a:t>Capital goes into the Japan operating entity (K.K.). The U.S. parent retains majority and control — clean for both Japan FDI (FEFTA) and U.S. (CFIUS).</a:t>
+              <a:t>Investors invest through the Exos U.S. offering vehicle; proceeds fund the build-out of Exos Aerospace Japan (K.K.), a wholly-owned subsidiary.</a:t>
             </a:r>
           </a:p>
         </p:txBody>
@@ -6040,7 +6040,7 @@
                 </a:solidFill>
                 <a:latin typeface="Aptos"/>
               </a:rPr>
-              <a:t>SEED ROUND — INTO THE K.K.</a:t>
+              <a:t>JAPAN ROUND — VIA EXOS U.S.</a:t>
             </a:r>
           </a:p>
         </p:txBody>
@@ -6215,19 +6215,7 @@
                 </a:solidFill>
                 <a:latin typeface="Aptos"/>
               </a:rPr>
-              <a:t>Seed now into the K.K.  →  growth round as Japan revenue scales  →  alignment with an Exos US liquidity event.</a:t>
-            </a:r>
-          </a:p>
-          <a:p>
-            <a:pPr algn="l"/>
-            <a:r>
-              <a:rPr sz="1300" b="0">
-                <a:solidFill>
-                  <a:srgbClr val="B1B4B9"/>
-                </a:solidFill>
-                <a:latin typeface="Aptos"/>
-              </a:rPr>
-              <a:t>Round sized to Japan build-out milestones; priced off the Exos US Series A.</a:t>
+              <a:t>Japan round now via Exos U.S.  →  proceeds fund the K.K. build-out  →  growth as Japan revenue scales. Priced off the Exos U.S. valuation.</a:t>
             </a:r>
           </a:p>
         </p:txBody>
@@ -6936,7 +6924,7 @@
                 </a:solidFill>
                 <a:latin typeface="Aptos"/>
               </a:rPr>
-              <a:t>The U.S. parent retains majority and control; the Japan entity runs Japan operations. The structure is modeled on the established Exos Aerospace Italia subsidiary.</a:t>
+              <a:t>Exos Aerospace Japan K.K. is a wholly-owned subsidiary of Exos U.S., modeled on the established Exos Aerospace Italia subsidiary. Investors hold a minority interest in Exos U.S.</a:t>
             </a:r>
           </a:p>
         </p:txBody>
@@ -6971,7 +6959,7 @@
                 </a:solidFill>
                 <a:latin typeface="Aptos"/>
               </a:rPr>
-              <a:t>Not an offer of securities of Exos Aerospace Systems &amp; Technologies, Inc. Any offering by Exos Aerospace Japan K.K. will be made only through definitive documents to eligible investors.</a:t>
+              <a:t>This presentation is not an offer to sell or a solicitation of an offer to buy securities. Any offering will be made only through definitive offering documents to eligible investors.</a:t>
             </a:r>
           </a:p>
         </p:txBody>
@@ -7227,7 +7215,7 @@
                 </a:solidFill>
                 <a:latin typeface="Aptos"/>
               </a:rPr>
-              <a:t>SEED (NOW)</a:t>
+              <a:t>ROUND (NOW)</a:t>
             </a:r>
           </a:p>
         </p:txBody>
@@ -7564,7 +7552,7 @@
                 </a:solidFill>
                 <a:latin typeface="Aptos"/>
               </a:rPr>
-              <a:t>Liquidity paths: acquisition of the K.K. stake by Exos U.S. or a strategic buyer, or a K.K.-level listing. Horizon ~3+ years.</a:t>
+              <a:t>Liquidity through an Exos U.S. event: public listing or acquisition. Horizon ~3+ years.</a:t>
             </a:r>
           </a:p>
         </p:txBody>
@@ -7936,7 +7924,7 @@
                 </a:solidFill>
                 <a:latin typeface="Aptos"/>
               </a:rPr>
-              <a:t>Not an offer of securities of Exos Aerospace Systems &amp; Technologies, Inc. Any offering by Exos Aerospace Japan K.K. will be made only through definitive documents to eligible investors.</a:t>
+              <a:t>This presentation is not an offer to sell or a solicitation of an offer to buy securities. Any offering will be made only through definitive offering documents to eligible investors.</a:t>
             </a:r>
           </a:p>
         </p:txBody>

</xml_diff>

<commit_message>
IDJ decks: Japan round = sale of EAI LLC units, separate offshore Reg S offering (Jon 9/27)
Co-Authored-By: Claude Opus 5.5 <noreply@anthropic.com>
</commit_message>
<xml_diff>
--- a/drafts/Exos_Aerospace_Japan_Investor_Pitch_Rev2_2026-09-27.pptx
+++ b/drafts/Exos_Aerospace_Japan_Investor_Pitch_Rev2_2026-09-27.pptx
@@ -5845,7 +5845,7 @@
                 </a:solidFill>
                 <a:latin typeface="Aptos"/>
               </a:rPr>
-              <a:t>Investors invest through the Exos U.S. offering vehicle; proceeds fund the build-out of Exos Aerospace Japan (K.K.), a wholly-owned subsidiary.</a:t>
+              <a:t>Investors buy units in Exos Aerospace Investments, LLC (offshore Reg S); proceeds fund Exos Aerospace Japan (K.K.), a wholly-owned subsidiary.</a:t>
             </a:r>
           </a:p>
         </p:txBody>
@@ -6040,7 +6040,7 @@
                 </a:solidFill>
                 <a:latin typeface="Aptos"/>
               </a:rPr>
-              <a:t>JAPAN ROUND — VIA EXOS U.S.</a:t>
+              <a:t>JAPAN ROUND — REG S, VIA EAI LLC</a:t>
             </a:r>
           </a:p>
         </p:txBody>
@@ -6215,7 +6215,7 @@
                 </a:solidFill>
                 <a:latin typeface="Aptos"/>
               </a:rPr>
-              <a:t>Japan round now via Exos U.S.  →  proceeds fund the K.K. build-out  →  growth as Japan revenue scales. Priced off the Exos U.S. valuation.</a:t>
+              <a:t>Offshore Reg S round into EAI LLC now  →  proceeds fund the K.K. build-out  →  growth as Japan revenue scales. Priced off the Exos U.S. valuation.</a:t>
             </a:r>
           </a:p>
         </p:txBody>
@@ -6924,7 +6924,7 @@
                 </a:solidFill>
                 <a:latin typeface="Aptos"/>
               </a:rPr>
-              <a:t>Exos Aerospace Japan K.K. is a wholly-owned subsidiary of Exos U.S., modeled on the established Exos Aerospace Italia subsidiary. Investors hold a minority interest in Exos U.S.</a:t>
+              <a:t>Investors hold units in Exos Aerospace Investments, LLC, which holds a minority interest in Exos U.S. Exos Aerospace Japan K.K. is a wholly-owned subsidiary of Exos U.S., modeled on Exos Aerospace Italia.</a:t>
             </a:r>
           </a:p>
         </p:txBody>
@@ -6937,16 +6937,16 @@
         </p:nvSpPr>
         <p:spPr>
           <a:xfrm>
-            <a:off x="594360" y="6199632"/>
-            <a:ext cx="10515600" cy="228600"/>
-          </a:xfrm>
-          <a:prstGeom prst="rect">
-            <a:avLst/>
-          </a:prstGeom>
-          <a:noFill/>
-        </p:spPr>
-        <p:txBody>
-          <a:bodyPr wrap="none" lIns="18288" tIns="18288" rIns="18288" bIns="18288" anchor="t">
+            <a:off x="594360" y="6053328"/>
+            <a:ext cx="10515600" cy="411480"/>
+          </a:xfrm>
+          <a:prstGeom prst="rect">
+            <a:avLst/>
+          </a:prstGeom>
+          <a:noFill/>
+        </p:spPr>
+        <p:txBody>
+          <a:bodyPr wrap="square" lIns="18288" tIns="18288" rIns="18288" bIns="18288" anchor="t">
             <a:spAutoFit/>
           </a:bodyPr>
           <a:lstStyle/>
@@ -6959,7 +6959,7 @@
                 </a:solidFill>
                 <a:latin typeface="Aptos"/>
               </a:rPr>
-              <a:t>This presentation is not an offer to sell or a solicitation of an offer to buy securities. Any offering will be made only through definitive offering documents to eligible investors.</a:t>
+              <a:t>Not an offer to sell or a solicitation of an offer to buy securities. Units of Exos Aerospace Investments, LLC are offered only to non-U.S. persons in offshore transactions under Regulation S, separate from any U.S. offering, and only through definitive offering documents. Not registered under the U.S. Securities Act; may not be offered or sold in the U.S. or to U.S. persons absent registration or an exemption.</a:t>
             </a:r>
           </a:p>
         </p:txBody>
@@ -7552,7 +7552,7 @@
                 </a:solidFill>
                 <a:latin typeface="Aptos"/>
               </a:rPr>
-              <a:t>Liquidity through an Exos U.S. event: public listing or acquisition. Horizon ~3+ years.</a:t>
+              <a:t>Liquidity through an Exos U.S. event (public listing or acquisition), realized via EAI LLC. Horizon ~3+ years.</a:t>
             </a:r>
           </a:p>
         </p:txBody>
@@ -7902,8 +7902,8 @@
         </p:nvSpPr>
         <p:spPr>
           <a:xfrm>
-            <a:off x="594360" y="6199632"/>
-            <a:ext cx="10515600" cy="228600"/>
+            <a:off x="594360" y="6053328"/>
+            <a:ext cx="10515600" cy="411480"/>
           </a:xfrm>
           <a:prstGeom prst="rect">
             <a:avLst/>
@@ -7924,7 +7924,7 @@
                 </a:solidFill>
                 <a:latin typeface="Aptos"/>
               </a:rPr>
-              <a:t>This presentation is not an offer to sell or a solicitation of an offer to buy securities. Any offering will be made only through definitive offering documents to eligible investors.</a:t>
+              <a:t>Not an offer to sell or a solicitation of an offer to buy securities. Units of Exos Aerospace Investments, LLC are offered only to non-U.S. persons in offshore transactions under Regulation S, separate from any U.S. offering, and only through definitive offering documents. Not registered under the U.S. Securities Act; may not be offered or sold in the U.S. or to U.S. persons absent registration or an exemption.</a:t>
             </a:r>
           </a:p>
         </p:txBody>

</xml_diff>